<commit_message>
Luxury preview: solid rule under the last luxury store
Co-Authored-By: Claude Opus 5.5 <noreply@anthropic.com>
Claude-Session: https://claude.ai/code/session_01Xa4nFVxuQGXmHARGph9WhS
</commit_message>
<xml_diff>
--- a/day2-deck/decks/Luxury Slide - Preview.pptx
+++ b/day2-deck/decks/Luxury Slide - Preview.pptx
@@ -2444,7 +2444,27 @@
       </p:sp>
       <p:sp>
         <p:nvSpPr>
-          <p:cNvPr id="49" name="Text 47"/>
+          <p:cNvPr id="49" name="Shape 47"/>
+          <p:cNvSpPr/>
+          <p:nvPr/>
+        </p:nvSpPr>
+        <p:spPr>
+          <a:xfrm>
+            <a:off x="658368" y="4297680"/>
+            <a:ext cx="5303520" cy="18288"/>
+          </a:xfrm>
+          <a:prstGeom prst="rect">
+            <a:avLst/>
+          </a:prstGeom>
+          <a:solidFill>
+            <a:srgbClr val="0B2C4A"/>
+          </a:solidFill>
+          <a:ln/>
+        </p:spPr>
+      </p:sp>
+      <p:sp>
+        <p:nvSpPr>
+          <p:cNvPr id="50" name="Text 48"/>
           <p:cNvSpPr txBox="1"/>
           <p:nvPr/>
         </p:nvSpPr>
@@ -2483,7 +2503,7 @@
       </p:sp>
       <p:sp>
         <p:nvSpPr>
-          <p:cNvPr id="50" name="Shape 48"/>
+          <p:cNvPr id="51" name="Shape 49"/>
           <p:cNvSpPr/>
           <p:nvPr/>
         </p:nvSpPr>
@@ -2503,7 +2523,7 @@
       </p:sp>
       <p:sp>
         <p:nvSpPr>
-          <p:cNvPr id="51" name="Text 49"/>
+          <p:cNvPr id="52" name="Text 50"/>
           <p:cNvSpPr txBox="1"/>
           <p:nvPr/>
         </p:nvSpPr>
@@ -2542,7 +2562,7 @@
       </p:sp>
       <p:sp>
         <p:nvSpPr>
-          <p:cNvPr id="52" name="Text 50"/>
+          <p:cNvPr id="53" name="Text 51"/>
           <p:cNvSpPr txBox="1"/>
           <p:nvPr/>
         </p:nvSpPr>
@@ -2581,7 +2601,7 @@
       </p:sp>
       <p:sp>
         <p:nvSpPr>
-          <p:cNvPr id="53" name="Shape 51"/>
+          <p:cNvPr id="54" name="Shape 52"/>
           <p:cNvSpPr/>
           <p:nvPr/>
         </p:nvSpPr>
@@ -2601,7 +2621,7 @@
       </p:sp>
       <p:sp>
         <p:nvSpPr>
-          <p:cNvPr id="54" name="Text 52"/>
+          <p:cNvPr id="55" name="Text 53"/>
           <p:cNvSpPr txBox="1"/>
           <p:nvPr/>
         </p:nvSpPr>
@@ -2640,7 +2660,7 @@
       </p:sp>
       <p:sp>
         <p:nvSpPr>
-          <p:cNvPr id="55" name="Text 53"/>
+          <p:cNvPr id="56" name="Text 54"/>
           <p:cNvSpPr txBox="1"/>
           <p:nvPr/>
         </p:nvSpPr>
@@ -2679,7 +2699,7 @@
       </p:sp>
       <p:sp>
         <p:nvSpPr>
-          <p:cNvPr id="56" name="Text 54"/>
+          <p:cNvPr id="57" name="Text 55"/>
           <p:cNvSpPr txBox="1"/>
           <p:nvPr/>
         </p:nvSpPr>
@@ -2718,7 +2738,7 @@
       </p:sp>
       <p:sp>
         <p:nvSpPr>
-          <p:cNvPr id="57" name="Shape 55"/>
+          <p:cNvPr id="58" name="Shape 56"/>
           <p:cNvSpPr/>
           <p:nvPr/>
         </p:nvSpPr>
@@ -2738,7 +2758,7 @@
       </p:sp>
       <p:sp>
         <p:nvSpPr>
-          <p:cNvPr id="58" name="Text 56"/>
+          <p:cNvPr id="59" name="Text 57"/>
           <p:cNvSpPr txBox="1"/>
           <p:nvPr/>
         </p:nvSpPr>
@@ -2777,7 +2797,7 @@
       </p:sp>
       <p:sp>
         <p:nvSpPr>
-          <p:cNvPr id="59" name="Text 57"/>
+          <p:cNvPr id="60" name="Text 58"/>
           <p:cNvSpPr txBox="1"/>
           <p:nvPr/>
         </p:nvSpPr>
@@ -2816,7 +2836,7 @@
       </p:sp>
       <p:sp>
         <p:nvSpPr>
-          <p:cNvPr id="60" name="Text 58"/>
+          <p:cNvPr id="61" name="Text 59"/>
           <p:cNvSpPr txBox="1"/>
           <p:nvPr/>
         </p:nvSpPr>
@@ -2855,7 +2875,7 @@
       </p:sp>
       <p:sp>
         <p:nvSpPr>
-          <p:cNvPr id="61" name="Shape 59"/>
+          <p:cNvPr id="62" name="Shape 60"/>
           <p:cNvSpPr/>
           <p:nvPr/>
         </p:nvSpPr>
@@ -2875,7 +2895,7 @@
       </p:sp>
       <p:sp>
         <p:nvSpPr>
-          <p:cNvPr id="62" name="Text 60"/>
+          <p:cNvPr id="63" name="Text 61"/>
           <p:cNvSpPr txBox="1"/>
           <p:nvPr/>
         </p:nvSpPr>
@@ -2914,7 +2934,7 @@
       </p:sp>
       <p:sp>
         <p:nvSpPr>
-          <p:cNvPr id="63" name="Text 61"/>
+          <p:cNvPr id="64" name="Text 62"/>
           <p:cNvSpPr txBox="1"/>
           <p:nvPr/>
         </p:nvSpPr>
@@ -2953,7 +2973,7 @@
       </p:sp>
       <p:sp>
         <p:nvSpPr>
-          <p:cNvPr id="64" name="Text 62"/>
+          <p:cNvPr id="65" name="Text 63"/>
           <p:cNvSpPr txBox="1"/>
           <p:nvPr/>
         </p:nvSpPr>
@@ -2992,7 +3012,7 @@
       </p:sp>
       <p:sp>
         <p:nvSpPr>
-          <p:cNvPr id="65" name="Shape 63"/>
+          <p:cNvPr id="66" name="Shape 64"/>
           <p:cNvSpPr/>
           <p:nvPr/>
         </p:nvSpPr>
@@ -3012,7 +3032,7 @@
       </p:sp>
       <p:sp>
         <p:nvSpPr>
-          <p:cNvPr id="66" name="Text 64"/>
+          <p:cNvPr id="67" name="Text 65"/>
           <p:cNvSpPr txBox="1"/>
           <p:nvPr/>
         </p:nvSpPr>
@@ -3051,7 +3071,7 @@
       </p:sp>
       <p:sp>
         <p:nvSpPr>
-          <p:cNvPr id="67" name="Text 65"/>
+          <p:cNvPr id="68" name="Text 66"/>
           <p:cNvSpPr txBox="1"/>
           <p:nvPr/>
         </p:nvSpPr>
@@ -3090,7 +3110,7 @@
       </p:sp>
       <p:sp>
         <p:nvSpPr>
-          <p:cNvPr id="68" name="Text 66"/>
+          <p:cNvPr id="69" name="Text 67"/>
           <p:cNvSpPr txBox="1"/>
           <p:nvPr/>
         </p:nvSpPr>
@@ -3129,7 +3149,7 @@
       </p:sp>
       <p:sp>
         <p:nvSpPr>
-          <p:cNvPr id="69" name="Shape 67"/>
+          <p:cNvPr id="70" name="Shape 68"/>
           <p:cNvSpPr/>
           <p:nvPr/>
         </p:nvSpPr>
@@ -3149,7 +3169,7 @@
       </p:sp>
       <p:sp>
         <p:nvSpPr>
-          <p:cNvPr id="70" name="Text 68"/>
+          <p:cNvPr id="71" name="Text 69"/>
           <p:cNvSpPr txBox="1"/>
           <p:nvPr/>
         </p:nvSpPr>
@@ -3188,7 +3208,7 @@
       </p:sp>
       <p:sp>
         <p:nvSpPr>
-          <p:cNvPr id="71" name="Text 69"/>
+          <p:cNvPr id="72" name="Text 70"/>
           <p:cNvSpPr txBox="1"/>
           <p:nvPr/>
         </p:nvSpPr>
@@ -3227,7 +3247,7 @@
       </p:sp>
       <p:sp>
         <p:nvSpPr>
-          <p:cNvPr id="72" name="Text 70"/>
+          <p:cNvPr id="73" name="Text 71"/>
           <p:cNvSpPr txBox="1"/>
           <p:nvPr/>
         </p:nvSpPr>
@@ -3266,7 +3286,7 @@
       </p:sp>
       <p:sp>
         <p:nvSpPr>
-          <p:cNvPr id="73" name="Shape 71"/>
+          <p:cNvPr id="74" name="Shape 72"/>
           <p:cNvSpPr/>
           <p:nvPr/>
         </p:nvSpPr>
@@ -3286,7 +3306,7 @@
       </p:sp>
       <p:sp>
         <p:nvSpPr>
-          <p:cNvPr id="74" name="Text 72"/>
+          <p:cNvPr id="75" name="Text 73"/>
           <p:cNvSpPr txBox="1"/>
           <p:nvPr/>
         </p:nvSpPr>
@@ -3325,7 +3345,7 @@
       </p:sp>
       <p:sp>
         <p:nvSpPr>
-          <p:cNvPr id="75" name="Text 73"/>
+          <p:cNvPr id="76" name="Text 74"/>
           <p:cNvSpPr txBox="1"/>
           <p:nvPr/>
         </p:nvSpPr>
@@ -3364,7 +3384,7 @@
       </p:sp>
       <p:sp>
         <p:nvSpPr>
-          <p:cNvPr id="76" name="Text 74"/>
+          <p:cNvPr id="77" name="Text 75"/>
           <p:cNvSpPr txBox="1"/>
           <p:nvPr/>
         </p:nvSpPr>
@@ -3403,7 +3423,7 @@
       </p:sp>
       <p:sp>
         <p:nvSpPr>
-          <p:cNvPr id="77" name="Shape 75"/>
+          <p:cNvPr id="78" name="Shape 76"/>
           <p:cNvSpPr/>
           <p:nvPr/>
         </p:nvSpPr>
@@ -3423,7 +3443,7 @@
       </p:sp>
       <p:sp>
         <p:nvSpPr>
-          <p:cNvPr id="78" name="Text 76"/>
+          <p:cNvPr id="79" name="Text 77"/>
           <p:cNvSpPr txBox="1"/>
           <p:nvPr/>
         </p:nvSpPr>
@@ -3462,7 +3482,7 @@
       </p:sp>
       <p:sp>
         <p:nvSpPr>
-          <p:cNvPr id="79" name="Text 77"/>
+          <p:cNvPr id="80" name="Text 78"/>
           <p:cNvSpPr txBox="1"/>
           <p:nvPr/>
         </p:nvSpPr>
@@ -3501,7 +3521,7 @@
       </p:sp>
       <p:sp>
         <p:nvSpPr>
-          <p:cNvPr id="80" name="Shape 78"/>
+          <p:cNvPr id="81" name="Shape 79"/>
           <p:cNvSpPr/>
           <p:nvPr/>
         </p:nvSpPr>
@@ -3521,7 +3541,7 @@
       </p:sp>
       <p:sp>
         <p:nvSpPr>
-          <p:cNvPr id="81" name="Text 79"/>
+          <p:cNvPr id="82" name="Text 80"/>
           <p:cNvSpPr txBox="1"/>
           <p:nvPr/>
         </p:nvSpPr>
@@ -3560,7 +3580,7 @@
       </p:sp>
       <p:sp>
         <p:nvSpPr>
-          <p:cNvPr id="82" name="Text 80"/>
+          <p:cNvPr id="83" name="Text 81"/>
           <p:cNvSpPr txBox="1"/>
           <p:nvPr/>
         </p:nvSpPr>
@@ -3599,7 +3619,7 @@
       </p:sp>
       <p:sp>
         <p:nvSpPr>
-          <p:cNvPr id="83" name="Shape 81"/>
+          <p:cNvPr id="84" name="Shape 82"/>
           <p:cNvSpPr/>
           <p:nvPr/>
         </p:nvSpPr>
@@ -3619,7 +3639,7 @@
       </p:sp>
       <p:sp>
         <p:nvSpPr>
-          <p:cNvPr id="84" name="Text 82"/>
+          <p:cNvPr id="85" name="Text 83"/>
           <p:cNvSpPr txBox="1"/>
           <p:nvPr/>
         </p:nvSpPr>
@@ -3658,7 +3678,7 @@
       </p:sp>
       <p:sp>
         <p:nvSpPr>
-          <p:cNvPr id="85" name="Text 83"/>
+          <p:cNvPr id="86" name="Text 84"/>
           <p:cNvSpPr txBox="1"/>
           <p:nvPr/>
         </p:nvSpPr>
@@ -3697,7 +3717,7 @@
       </p:sp>
       <p:sp>
         <p:nvSpPr>
-          <p:cNvPr id="86" name="Text 84"/>
+          <p:cNvPr id="87" name="Text 85"/>
           <p:cNvSpPr txBox="1"/>
           <p:nvPr/>
         </p:nvSpPr>
@@ -3736,7 +3756,7 @@
       </p:sp>
       <p:sp>
         <p:nvSpPr>
-          <p:cNvPr id="87" name="Shape 85"/>
+          <p:cNvPr id="88" name="Shape 86"/>
           <p:cNvSpPr/>
           <p:nvPr/>
         </p:nvSpPr>
@@ -3756,7 +3776,7 @@
       </p:sp>
       <p:sp>
         <p:nvSpPr>
-          <p:cNvPr id="88" name="Text 86"/>
+          <p:cNvPr id="89" name="Text 87"/>
           <p:cNvSpPr txBox="1"/>
           <p:nvPr/>
         </p:nvSpPr>
@@ -3795,7 +3815,7 @@
       </p:sp>
       <p:sp>
         <p:nvSpPr>
-          <p:cNvPr id="89" name="Text 87"/>
+          <p:cNvPr id="90" name="Text 88"/>
           <p:cNvSpPr txBox="1"/>
           <p:nvPr/>
         </p:nvSpPr>
@@ -3834,7 +3854,7 @@
       </p:sp>
       <p:sp>
         <p:nvSpPr>
-          <p:cNvPr id="90" name="Text 88"/>
+          <p:cNvPr id="91" name="Text 89"/>
           <p:cNvSpPr txBox="1"/>
           <p:nvPr/>
         </p:nvSpPr>
@@ -3873,7 +3893,7 @@
       </p:sp>
       <p:sp>
         <p:nvSpPr>
-          <p:cNvPr id="91" name="Shape 89"/>
+          <p:cNvPr id="92" name="Shape 90"/>
           <p:cNvSpPr/>
           <p:nvPr/>
         </p:nvSpPr>
@@ -3893,7 +3913,7 @@
       </p:sp>
       <p:sp>
         <p:nvSpPr>
-          <p:cNvPr id="92" name="Text 90"/>
+          <p:cNvPr id="93" name="Text 91"/>
           <p:cNvSpPr txBox="1"/>
           <p:nvPr/>
         </p:nvSpPr>
@@ -3932,7 +3952,7 @@
       </p:sp>
       <p:sp>
         <p:nvSpPr>
-          <p:cNvPr id="93" name="Text 91"/>
+          <p:cNvPr id="94" name="Text 92"/>
           <p:cNvSpPr txBox="1"/>
           <p:nvPr/>
         </p:nvSpPr>
@@ -3971,7 +3991,7 @@
       </p:sp>
       <p:sp>
         <p:nvSpPr>
-          <p:cNvPr id="94" name="Text 92"/>
+          <p:cNvPr id="95" name="Text 93"/>
           <p:cNvSpPr txBox="1"/>
           <p:nvPr/>
         </p:nvSpPr>
@@ -4010,7 +4030,7 @@
       </p:sp>
       <p:sp>
         <p:nvSpPr>
-          <p:cNvPr id="95" name="Shape 93"/>
+          <p:cNvPr id="96" name="Shape 94"/>
           <p:cNvSpPr/>
           <p:nvPr/>
         </p:nvSpPr>
@@ -4030,7 +4050,7 @@
       </p:sp>
       <p:sp>
         <p:nvSpPr>
-          <p:cNvPr id="96" name="Text 94"/>
+          <p:cNvPr id="97" name="Text 95"/>
           <p:cNvSpPr txBox="1"/>
           <p:nvPr/>
         </p:nvSpPr>
@@ -4069,7 +4089,7 @@
       </p:sp>
       <p:sp>
         <p:nvSpPr>
-          <p:cNvPr id="97" name="Text 95"/>
+          <p:cNvPr id="98" name="Text 96"/>
           <p:cNvSpPr txBox="1"/>
           <p:nvPr/>
         </p:nvSpPr>
@@ -4108,7 +4128,7 @@
       </p:sp>
       <p:sp>
         <p:nvSpPr>
-          <p:cNvPr id="98" name="Text 96"/>
+          <p:cNvPr id="99" name="Text 97"/>
           <p:cNvSpPr txBox="1"/>
           <p:nvPr/>
         </p:nvSpPr>
@@ -4147,7 +4167,7 @@
       </p:sp>
       <p:sp>
         <p:nvSpPr>
-          <p:cNvPr id="99" name="Shape 97"/>
+          <p:cNvPr id="100" name="Shape 98"/>
           <p:cNvSpPr/>
           <p:nvPr/>
         </p:nvSpPr>
@@ -4167,7 +4187,7 @@
       </p:sp>
       <p:sp>
         <p:nvSpPr>
-          <p:cNvPr id="100" name="Text 98"/>
+          <p:cNvPr id="101" name="Text 99"/>
           <p:cNvSpPr txBox="1"/>
           <p:nvPr/>
         </p:nvSpPr>
@@ -4206,7 +4226,7 @@
       </p:sp>
       <p:sp>
         <p:nvSpPr>
-          <p:cNvPr id="101" name="Text 99"/>
+          <p:cNvPr id="102" name="Text 100"/>
           <p:cNvSpPr txBox="1"/>
           <p:nvPr/>
         </p:nvSpPr>
@@ -4245,7 +4265,7 @@
       </p:sp>
       <p:sp>
         <p:nvSpPr>
-          <p:cNvPr id="102" name="Text 100"/>
+          <p:cNvPr id="103" name="Text 101"/>
           <p:cNvSpPr txBox="1"/>
           <p:nvPr/>
         </p:nvSpPr>
@@ -4284,7 +4304,7 @@
       </p:sp>
       <p:sp>
         <p:nvSpPr>
-          <p:cNvPr id="103" name="Shape 101"/>
+          <p:cNvPr id="104" name="Shape 102"/>
           <p:cNvSpPr/>
           <p:nvPr/>
         </p:nvSpPr>
@@ -4304,7 +4324,7 @@
       </p:sp>
       <p:sp>
         <p:nvSpPr>
-          <p:cNvPr id="104" name="Text 102"/>
+          <p:cNvPr id="105" name="Text 103"/>
           <p:cNvSpPr txBox="1"/>
           <p:nvPr/>
         </p:nvSpPr>
@@ -4343,7 +4363,7 @@
       </p:sp>
       <p:sp>
         <p:nvSpPr>
-          <p:cNvPr id="105" name="Text 103"/>
+          <p:cNvPr id="106" name="Text 104"/>
           <p:cNvSpPr txBox="1"/>
           <p:nvPr/>
         </p:nvSpPr>
@@ -4382,7 +4402,7 @@
       </p:sp>
       <p:sp>
         <p:nvSpPr>
-          <p:cNvPr id="106" name="Text 104"/>
+          <p:cNvPr id="107" name="Text 105"/>
           <p:cNvSpPr txBox="1"/>
           <p:nvPr/>
         </p:nvSpPr>
@@ -4421,7 +4441,7 @@
       </p:sp>
       <p:sp>
         <p:nvSpPr>
-          <p:cNvPr id="107" name="Shape 105"/>
+          <p:cNvPr id="108" name="Shape 106"/>
           <p:cNvSpPr/>
           <p:nvPr/>
         </p:nvSpPr>
@@ -4441,7 +4461,7 @@
       </p:sp>
       <p:sp>
         <p:nvSpPr>
-          <p:cNvPr id="108" name="Text 106"/>
+          <p:cNvPr id="109" name="Text 107"/>
           <p:cNvSpPr txBox="1"/>
           <p:nvPr/>
         </p:nvSpPr>
@@ -4480,7 +4500,7 @@
       </p:sp>
       <p:sp>
         <p:nvSpPr>
-          <p:cNvPr id="109" name="Text 107"/>
+          <p:cNvPr id="110" name="Text 108"/>
           <p:cNvSpPr txBox="1"/>
           <p:nvPr/>
         </p:nvSpPr>
@@ -4519,7 +4539,7 @@
       </p:sp>
       <p:sp>
         <p:nvSpPr>
-          <p:cNvPr id="110" name="Text 108"/>
+          <p:cNvPr id="111" name="Text 109"/>
           <p:cNvSpPr txBox="1"/>
           <p:nvPr/>
         </p:nvSpPr>
@@ -4558,7 +4578,7 @@
       </p:sp>
       <p:sp>
         <p:nvSpPr>
-          <p:cNvPr id="111" name="Shape 109"/>
+          <p:cNvPr id="112" name="Shape 110"/>
           <p:cNvSpPr/>
           <p:nvPr/>
         </p:nvSpPr>
@@ -4578,7 +4598,7 @@
       </p:sp>
       <p:sp>
         <p:nvSpPr>
-          <p:cNvPr id="112" name="Text 110"/>
+          <p:cNvPr id="113" name="Text 111"/>
           <p:cNvSpPr txBox="1"/>
           <p:nvPr/>
         </p:nvSpPr>
@@ -4617,7 +4637,7 @@
       </p:sp>
       <p:sp>
         <p:nvSpPr>
-          <p:cNvPr id="113" name="Text 111"/>
+          <p:cNvPr id="114" name="Text 112"/>
           <p:cNvSpPr txBox="1"/>
           <p:nvPr/>
         </p:nvSpPr>
@@ -4656,7 +4676,7 @@
       </p:sp>
       <p:sp>
         <p:nvSpPr>
-          <p:cNvPr id="114" name="Text 112"/>
+          <p:cNvPr id="115" name="Text 113"/>
           <p:cNvSpPr txBox="1"/>
           <p:nvPr/>
         </p:nvSpPr>
@@ -4695,7 +4715,7 @@
       </p:sp>
       <p:sp>
         <p:nvSpPr>
-          <p:cNvPr id="115" name="Shape 113"/>
+          <p:cNvPr id="116" name="Shape 114"/>
           <p:cNvSpPr/>
           <p:nvPr/>
         </p:nvSpPr>
@@ -4715,7 +4735,7 @@
       </p:sp>
       <p:sp>
         <p:nvSpPr>
-          <p:cNvPr id="116" name="Text 114"/>
+          <p:cNvPr id="117" name="Text 115"/>
           <p:cNvSpPr txBox="1"/>
           <p:nvPr/>
         </p:nvSpPr>
@@ -4754,7 +4774,7 @@
       </p:sp>
       <p:sp>
         <p:nvSpPr>
-          <p:cNvPr id="117" name="Text 115"/>
+          <p:cNvPr id="118" name="Text 116"/>
           <p:cNvSpPr txBox="1"/>
           <p:nvPr/>
         </p:nvSpPr>
@@ -4793,7 +4813,7 @@
       </p:sp>
       <p:sp>
         <p:nvSpPr>
-          <p:cNvPr id="118" name="Text 116"/>
+          <p:cNvPr id="119" name="Text 117"/>
           <p:cNvSpPr txBox="1"/>
           <p:nvPr/>
         </p:nvSpPr>
@@ -4832,7 +4852,7 @@
       </p:sp>
       <p:sp>
         <p:nvSpPr>
-          <p:cNvPr id="119" name="Shape 117"/>
+          <p:cNvPr id="120" name="Shape 118"/>
           <p:cNvSpPr/>
           <p:nvPr/>
         </p:nvSpPr>
@@ -4852,7 +4872,7 @@
       </p:sp>
       <p:sp>
         <p:nvSpPr>
-          <p:cNvPr id="120" name="Text 118"/>
+          <p:cNvPr id="121" name="Text 119"/>
           <p:cNvSpPr txBox="1"/>
           <p:nvPr/>
         </p:nvSpPr>
@@ -4891,7 +4911,7 @@
       </p:sp>
       <p:sp>
         <p:nvSpPr>
-          <p:cNvPr id="121" name="Text 119"/>
+          <p:cNvPr id="122" name="Text 120"/>
           <p:cNvSpPr txBox="1"/>
           <p:nvPr/>
         </p:nvSpPr>
@@ -4930,7 +4950,7 @@
       </p:sp>
       <p:sp>
         <p:nvSpPr>
-          <p:cNvPr id="122" name="Text 120"/>
+          <p:cNvPr id="123" name="Text 121"/>
           <p:cNvSpPr txBox="1"/>
           <p:nvPr/>
         </p:nvSpPr>
@@ -4969,7 +4989,7 @@
       </p:sp>
       <p:sp>
         <p:nvSpPr>
-          <p:cNvPr id="123" name="Shape 121"/>
+          <p:cNvPr id="124" name="Shape 122"/>
           <p:cNvSpPr/>
           <p:nvPr/>
         </p:nvSpPr>
@@ -4989,7 +5009,7 @@
       </p:sp>
       <p:sp>
         <p:nvSpPr>
-          <p:cNvPr id="124" name="Text 122"/>
+          <p:cNvPr id="125" name="Text 123"/>
           <p:cNvSpPr txBox="1"/>
           <p:nvPr/>
         </p:nvSpPr>
@@ -5028,7 +5048,7 @@
       </p:sp>
       <p:sp>
         <p:nvSpPr>
-          <p:cNvPr id="125" name="Text 123"/>
+          <p:cNvPr id="126" name="Text 124"/>
           <p:cNvSpPr txBox="1"/>
           <p:nvPr/>
         </p:nvSpPr>
@@ -5067,7 +5087,7 @@
       </p:sp>
       <p:sp>
         <p:nvSpPr>
-          <p:cNvPr id="126" name="Text 124"/>
+          <p:cNvPr id="127" name="Text 125"/>
           <p:cNvSpPr txBox="1"/>
           <p:nvPr/>
         </p:nvSpPr>
@@ -5106,7 +5126,7 @@
       </p:sp>
       <p:sp>
         <p:nvSpPr>
-          <p:cNvPr id="127" name="Shape 125"/>
+          <p:cNvPr id="128" name="Shape 126"/>
           <p:cNvSpPr/>
           <p:nvPr/>
         </p:nvSpPr>
@@ -5126,7 +5146,7 @@
       </p:sp>
       <p:sp>
         <p:nvSpPr>
-          <p:cNvPr id="128" name="Text 126"/>
+          <p:cNvPr id="129" name="Text 127"/>
           <p:cNvSpPr txBox="1"/>
           <p:nvPr/>
         </p:nvSpPr>
@@ -5165,7 +5185,7 @@
       </p:sp>
       <p:sp>
         <p:nvSpPr>
-          <p:cNvPr id="129" name="Text 127"/>
+          <p:cNvPr id="130" name="Text 128"/>
           <p:cNvSpPr txBox="1"/>
           <p:nvPr/>
         </p:nvSpPr>
@@ -5204,7 +5224,7 @@
       </p:sp>
       <p:sp>
         <p:nvSpPr>
-          <p:cNvPr id="130" name="Text 128"/>
+          <p:cNvPr id="131" name="Text 129"/>
           <p:cNvSpPr txBox="1"/>
           <p:nvPr/>
         </p:nvSpPr>
@@ -5243,7 +5263,7 @@
       </p:sp>
       <p:sp>
         <p:nvSpPr>
-          <p:cNvPr id="131" name="Shape 129"/>
+          <p:cNvPr id="132" name="Shape 130"/>
           <p:cNvSpPr/>
           <p:nvPr/>
         </p:nvSpPr>
@@ -5263,7 +5283,7 @@
       </p:sp>
       <p:sp>
         <p:nvSpPr>
-          <p:cNvPr id="132" name="Text 130"/>
+          <p:cNvPr id="133" name="Text 131"/>
           <p:cNvSpPr txBox="1"/>
           <p:nvPr/>
         </p:nvSpPr>
@@ -5302,7 +5322,7 @@
       </p:sp>
       <p:sp>
         <p:nvSpPr>
-          <p:cNvPr id="133" name="Text 131"/>
+          <p:cNvPr id="134" name="Text 132"/>
           <p:cNvSpPr txBox="1"/>
           <p:nvPr/>
         </p:nvSpPr>
@@ -5341,7 +5361,7 @@
       </p:sp>
       <p:sp>
         <p:nvSpPr>
-          <p:cNvPr id="134" name="Text 132"/>
+          <p:cNvPr id="135" name="Text 133"/>
           <p:cNvSpPr txBox="1"/>
           <p:nvPr/>
         </p:nvSpPr>
@@ -5380,7 +5400,7 @@
       </p:sp>
       <p:sp>
         <p:nvSpPr>
-          <p:cNvPr id="135" name="Shape 133"/>
+          <p:cNvPr id="136" name="Shape 134"/>
           <p:cNvSpPr/>
           <p:nvPr/>
         </p:nvSpPr>
@@ -5400,7 +5420,7 @@
       </p:sp>
       <p:sp>
         <p:nvSpPr>
-          <p:cNvPr id="136" name="Text 134"/>
+          <p:cNvPr id="137" name="Text 135"/>
           <p:cNvSpPr txBox="1"/>
           <p:nvPr/>
         </p:nvSpPr>
@@ -5439,7 +5459,7 @@
       </p:sp>
       <p:sp>
         <p:nvSpPr>
-          <p:cNvPr id="137" name="Text 135"/>
+          <p:cNvPr id="138" name="Text 136"/>
           <p:cNvSpPr txBox="1"/>
           <p:nvPr/>
         </p:nvSpPr>
@@ -5478,7 +5498,7 @@
       </p:sp>
       <p:sp>
         <p:nvSpPr>
-          <p:cNvPr id="138" name="Text 136"/>
+          <p:cNvPr id="139" name="Text 137"/>
           <p:cNvSpPr txBox="1"/>
           <p:nvPr/>
         </p:nvSpPr>
@@ -5517,7 +5537,7 @@
       </p:sp>
       <p:sp>
         <p:nvSpPr>
-          <p:cNvPr id="139" name="Shape 137"/>
+          <p:cNvPr id="140" name="Shape 138"/>
           <p:cNvSpPr/>
           <p:nvPr/>
         </p:nvSpPr>
@@ -5537,7 +5557,7 @@
       </p:sp>
       <p:sp>
         <p:nvSpPr>
-          <p:cNvPr id="140" name="Text 138"/>
+          <p:cNvPr id="141" name="Text 139"/>
           <p:cNvSpPr txBox="1"/>
           <p:nvPr/>
         </p:nvSpPr>
@@ -5576,7 +5596,7 @@
       </p:sp>
       <p:sp>
         <p:nvSpPr>
-          <p:cNvPr id="141" name="Text 139"/>
+          <p:cNvPr id="142" name="Text 140"/>
           <p:cNvSpPr txBox="1"/>
           <p:nvPr/>
         </p:nvSpPr>
@@ -5615,7 +5635,7 @@
       </p:sp>
       <p:sp>
         <p:nvSpPr>
-          <p:cNvPr id="142" name="Text 140"/>
+          <p:cNvPr id="143" name="Text 141"/>
           <p:cNvSpPr txBox="1"/>
           <p:nvPr/>
         </p:nvSpPr>
@@ -5654,7 +5674,7 @@
       </p:sp>
       <p:sp>
         <p:nvSpPr>
-          <p:cNvPr id="143" name="Shape 141"/>
+          <p:cNvPr id="144" name="Shape 142"/>
           <p:cNvSpPr/>
           <p:nvPr/>
         </p:nvSpPr>
@@ -5674,7 +5694,7 @@
       </p:sp>
       <p:sp>
         <p:nvSpPr>
-          <p:cNvPr id="144" name="Text 142"/>
+          <p:cNvPr id="145" name="Text 143"/>
           <p:cNvSpPr txBox="1"/>
           <p:nvPr/>
         </p:nvSpPr>
@@ -5713,7 +5733,7 @@
       </p:sp>
       <p:sp>
         <p:nvSpPr>
-          <p:cNvPr id="145" name="Text 143"/>
+          <p:cNvPr id="146" name="Text 144"/>
           <p:cNvSpPr txBox="1"/>
           <p:nvPr/>
         </p:nvSpPr>
@@ -5752,7 +5772,7 @@
       </p:sp>
       <p:sp>
         <p:nvSpPr>
-          <p:cNvPr id="146" name="Text 144"/>
+          <p:cNvPr id="147" name="Text 145"/>
           <p:cNvSpPr txBox="1"/>
           <p:nvPr/>
         </p:nvSpPr>
@@ -5791,7 +5811,7 @@
       </p:sp>
       <p:sp>
         <p:nvSpPr>
-          <p:cNvPr id="147" name="Shape 145"/>
+          <p:cNvPr id="148" name="Shape 146"/>
           <p:cNvSpPr/>
           <p:nvPr/>
         </p:nvSpPr>
@@ -5811,7 +5831,7 @@
       </p:sp>
       <p:sp>
         <p:nvSpPr>
-          <p:cNvPr id="148" name="Text 146"/>
+          <p:cNvPr id="149" name="Text 147"/>
           <p:cNvSpPr txBox="1"/>
           <p:nvPr/>
         </p:nvSpPr>
@@ -5850,7 +5870,7 @@
       </p:sp>
       <p:sp>
         <p:nvSpPr>
-          <p:cNvPr id="149" name="Shape 147"/>
+          <p:cNvPr id="150" name="Shape 148"/>
           <p:cNvSpPr/>
           <p:nvPr/>
         </p:nvSpPr>
@@ -5870,7 +5890,7 @@
       </p:sp>
       <p:sp>
         <p:nvSpPr>
-          <p:cNvPr id="150" name="Shape 148"/>
+          <p:cNvPr id="151" name="Shape 149"/>
           <p:cNvSpPr/>
           <p:nvPr/>
         </p:nvSpPr>
@@ -5890,7 +5910,7 @@
       </p:sp>
       <p:sp>
         <p:nvSpPr>
-          <p:cNvPr id="151" name="Shape 149"/>
+          <p:cNvPr id="152" name="Shape 150"/>
           <p:cNvSpPr/>
           <p:nvPr/>
         </p:nvSpPr>
@@ -5910,7 +5930,7 @@
       </p:sp>
       <p:sp>
         <p:nvSpPr>
-          <p:cNvPr id="152" name="Shape 150"/>
+          <p:cNvPr id="153" name="Shape 151"/>
           <p:cNvSpPr/>
           <p:nvPr/>
         </p:nvSpPr>

</xml_diff>